<commit_message>
docs: atualizar pptx com a página de QR do site
A última página traz o QR code ao lado da URL pública para abrir a demo
direto do celular.
</commit_message>
<xml_diff>
--- a/slides/console-automacao-identidade.pptx
+++ b/slides/console-automacao-identidade.pptx
@@ -15,6 +15,7 @@
     <p:sldId id="264" r:id="rId10"/>
     <p:sldId id="265" r:id="rId11"/>
     <p:sldId id="267" r:id="rId13"/>
+    <p:sldId id="270" r:id="rId16"/>
   </p:sldIdLst>
   <p:sldSz cx="12192000" cy="6858000"/>
   <p:notesSz cx="6858000" cy="9144000"/>
@@ -2675,6 +2676,587 @@
           </a:p>
         </p:txBody>
       </p:sp>
+    </p:spTree>
+  </p:cSld>
+  <p:clrMapOvr>
+    <a:masterClrMapping/>
+  </p:clrMapOvr>
+</p:sld>
+</file>
+
+<file path=ppt/slides/slide15.xml><?xml version="1.0" encoding="utf-8"?>
+<p:sld xmlns:a="http://schemas.openxmlformats.org/drawingml/2006/main" xmlns:r="http://schemas.openxmlformats.org/officeDocument/2006/relationships" xmlns:p="http://schemas.openxmlformats.org/presentationml/2006/main">
+  <p:cSld>
+    <p:bg>
+      <p:bgPr>
+        <a:solidFill>
+          <a:srgbClr val="0D1117"/>
+        </a:solidFill>
+        <a:effectLst/>
+      </p:bgPr>
+    </p:bg>
+    <p:spTree>
+      <p:nvGrpSpPr>
+        <p:cNvPr id="1" name=""/>
+        <p:cNvGrpSpPr/>
+        <p:nvPr/>
+      </p:nvGrpSpPr>
+      <p:grpSpPr>
+        <a:xfrm>
+          <a:off x="0" y="0"/>
+          <a:ext cx="0" cy="0"/>
+          <a:chOff x="0" y="0"/>
+          <a:chExt cx="0" cy="0"/>
+        </a:xfrm>
+      </p:grpSpPr>
+      <p:sp>
+        <p:nvSpPr>
+          <p:cNvPr id="3" name="TextBox 3">
+            <a:extLst>
+              <a:ext uri="{FF2B5EF4-FFF2-40B4-BE49-F238E27FC236}">
+                <a16:creationId xmlns:a16="http://schemas.microsoft.com/office/drawing/2014/main" id="{2C089E12-BBB8-4FDA-9CE1-EAD7191B65D6}"/>
+              </a:ext>
+            </a:extLst>
+          </p:cNvPr>
+          <p:cNvSpPr txBox="1"/>
+          <p:nvPr/>
+        </p:nvSpPr>
+        <p:spPr>
+          <a:xfrm>
+            <a:off x="762000" y="533400"/>
+            <a:ext cx="5715000" cy="247650"/>
+          </a:xfrm>
+        </p:spPr>
+        <p:txBody>
+          <a:bodyPr wrap="square" rtlCol="0" lIns="0" tIns="0" rIns="0" bIns="0" anchor="t"/>
+          <a:lstStyle/>
+          <a:p>
+            <a:pPr algn="l">
+              <a:lnSpc>
+                <a:spcPct val="110000"/>
+              </a:lnSpc>
+            </a:pPr>
+            <a:r>
+              <a:rPr sz="1300" b="1">
+                <a:solidFill>
+                  <a:srgbClr val="4EA1FF"/>
+                </a:solidFill>
+                <a:latin typeface="Segoe UI"/>
+                <a:ea typeface="Segoe UI"/>
+              </a:rPr>
+              <a:t>PARA ABRIR AGORA</a:t>
+            </a:r>
+          </a:p>
+        </p:txBody>
+      </p:sp>
+      <p:sp>
+        <p:nvSpPr>
+          <p:cNvPr id="4" name="TextBox 4">
+            <a:extLst>
+              <a:ext uri="{FF2B5EF4-FFF2-40B4-BE49-F238E27FC236}">
+                <a16:creationId xmlns:a16="http://schemas.microsoft.com/office/drawing/2014/main" id="{777368A7-22BB-41BD-9E34-D28E06EAEF51}"/>
+              </a:ext>
+            </a:extLst>
+          </p:cNvPr>
+          <p:cNvSpPr txBox="1"/>
+          <p:nvPr/>
+        </p:nvSpPr>
+        <p:spPr>
+          <a:xfrm>
+            <a:off x="762000" y="838200"/>
+            <a:ext cx="6096000" cy="569976"/>
+          </a:xfrm>
+        </p:spPr>
+        <p:txBody>
+          <a:bodyPr wrap="square" rtlCol="0" lIns="0" tIns="0" rIns="0" bIns="0" anchor="t"/>
+          <a:lstStyle/>
+          <a:p>
+            <a:pPr algn="l">
+              <a:lnSpc>
+                <a:spcPct val="110000"/>
+              </a:lnSpc>
+            </a:pPr>
+            <a:r>
+              <a:rPr sz="3400" b="1">
+                <a:solidFill>
+                  <a:srgbClr val="D9E2EC"/>
+                </a:solidFill>
+                <a:latin typeface="Segoe UI"/>
+                <a:ea typeface="Segoe UI"/>
+              </a:rPr>
+              <a:t>O site, direto no celular</a:t>
+            </a:r>
+          </a:p>
+        </p:txBody>
+      </p:sp>
+      <p:sp>
+        <p:nvSpPr>
+          <p:cNvPr id="5" name="TextBox 5">
+            <a:extLst>
+              <a:ext uri="{FF2B5EF4-FFF2-40B4-BE49-F238E27FC236}">
+                <a16:creationId xmlns:a16="http://schemas.microsoft.com/office/drawing/2014/main" id="{1E4E34B7-6159-4A8A-8A57-2865ED7212DF}"/>
+              </a:ext>
+            </a:extLst>
+          </p:cNvPr>
+          <p:cNvSpPr txBox="1"/>
+          <p:nvPr/>
+        </p:nvSpPr>
+        <p:spPr>
+          <a:xfrm>
+            <a:off x="762000" y="1447800"/>
+            <a:ext cx="5905500" cy="666750"/>
+          </a:xfrm>
+        </p:spPr>
+        <p:txBody>
+          <a:bodyPr wrap="square" rtlCol="0" lIns="0" tIns="0" rIns="0" bIns="0" anchor="t"/>
+          <a:lstStyle/>
+          <a:p>
+            <a:pPr algn="l">
+              <a:lnSpc>
+                <a:spcPct val="125000"/>
+              </a:lnSpc>
+            </a:pPr>
+            <a:r>
+              <a:rPr sz="1500">
+                <a:solidFill>
+                  <a:srgbClr val="8B99A8"/>
+                </a:solidFill>
+                <a:latin typeface="Segoe UI"/>
+                <a:ea typeface="Segoe UI"/>
+              </a:rPr>
+              <a:t>Aponte a câmera para o código ao lado. O console abre no navegador, sem instalar nada.</a:t>
+            </a:r>
+          </a:p>
+        </p:txBody>
+      </p:sp>
+      <p:sp>
+        <p:nvSpPr>
+          <p:cNvPr id="6" name="Shape 6">
+            <a:extLst>
+              <a:ext uri="{FF2B5EF4-FFF2-40B4-BE49-F238E27FC236}">
+                <a16:creationId xmlns:a16="http://schemas.microsoft.com/office/drawing/2014/main" id="{595460F4-59E5-4992-A441-1F5353AE5DFF}"/>
+              </a:ext>
+            </a:extLst>
+          </p:cNvPr>
+          <p:cNvSpPr/>
+          <p:nvPr/>
+        </p:nvSpPr>
+        <p:spPr>
+          <a:xfrm>
+            <a:off x="762000" y="2247900"/>
+            <a:ext cx="6096000" cy="590550"/>
+          </a:xfrm>
+          <a:prstGeom prst="roundRect">
+            <a:avLst/>
+          </a:prstGeom>
+          <a:solidFill>
+            <a:srgbClr val="12202C"/>
+          </a:solidFill>
+          <a:ln w="12700">
+            <a:solidFill>
+              <a:srgbClr val="2B4B6B"/>
+            </a:solidFill>
+          </a:ln>
+        </p:spPr>
+        <p:txBody>
+          <a:bodyPr wrap="square" rtlCol="0"/>
+          <a:lstStyle/>
+          <a:p>
+            <a:r>
+              <a:rPr/>
+              <a:t/>
+            </a:r>
+          </a:p>
+        </p:txBody>
+      </p:sp>
+      <p:sp>
+        <p:nvSpPr>
+          <p:cNvPr id="7" name="TextBox 7">
+            <a:extLst>
+              <a:ext uri="{FF2B5EF4-FFF2-40B4-BE49-F238E27FC236}">
+                <a16:creationId xmlns:a16="http://schemas.microsoft.com/office/drawing/2014/main" id="{AA256FA9-4E74-491C-8B3C-EEEC9C12DF7C}"/>
+              </a:ext>
+            </a:extLst>
+          </p:cNvPr>
+          <p:cNvSpPr txBox="1"/>
+          <p:nvPr/>
+        </p:nvSpPr>
+        <p:spPr>
+          <a:xfrm>
+            <a:off x="952500" y="2400300"/>
+            <a:ext cx="5715000" cy="285750"/>
+          </a:xfrm>
+        </p:spPr>
+        <p:txBody>
+          <a:bodyPr wrap="square" rtlCol="0" lIns="0" tIns="0" rIns="0" bIns="0" anchor="t"/>
+          <a:lstStyle/>
+          <a:p>
+            <a:pPr algn="l">
+              <a:lnSpc>
+                <a:spcPct val="110000"/>
+              </a:lnSpc>
+            </a:pPr>
+            <a:r>
+              <a:rPr sz="1500">
+                <a:solidFill>
+                  <a:srgbClr val="4EA1FF"/>
+                </a:solidFill>
+                <a:latin typeface="Consolas"/>
+                <a:ea typeface="Consolas"/>
+              </a:rPr>
+              <a:t>vitorvieira42.github.io/console-automacao-identidade</a:t>
+            </a:r>
+          </a:p>
+        </p:txBody>
+      </p:sp>
+      <p:sp>
+        <p:nvSpPr>
+          <p:cNvPr id="8" name="TextBox 8">
+            <a:extLst>
+              <a:ext uri="{FF2B5EF4-FFF2-40B4-BE49-F238E27FC236}">
+                <a16:creationId xmlns:a16="http://schemas.microsoft.com/office/drawing/2014/main" id="{4CDA3BF6-825B-4CA3-8F63-929AB23AA0AA}"/>
+              </a:ext>
+            </a:extLst>
+          </p:cNvPr>
+          <p:cNvSpPr txBox="1"/>
+          <p:nvPr/>
+        </p:nvSpPr>
+        <p:spPr>
+          <a:xfrm>
+            <a:off x="762000" y="3105150"/>
+            <a:ext cx="6096000" cy="266700"/>
+          </a:xfrm>
+        </p:spPr>
+        <p:txBody>
+          <a:bodyPr wrap="square" rtlCol="0" lIns="0" tIns="0" rIns="0" bIns="0" anchor="t"/>
+          <a:lstStyle/>
+          <a:p>
+            <a:pPr algn="l">
+              <a:lnSpc>
+                <a:spcPct val="110000"/>
+              </a:lnSpc>
+            </a:pPr>
+            <a:r>
+              <a:rPr sz="1300" b="1">
+                <a:solidFill>
+                  <a:srgbClr val="D9E2EC"/>
+                </a:solidFill>
+                <a:latin typeface="Segoe UI"/>
+                <a:ea typeface="Segoe UI"/>
+              </a:rPr>
+              <a:t>O que vale testar primeiro</a:t>
+            </a:r>
+          </a:p>
+        </p:txBody>
+      </p:sp>
+      <p:sp>
+        <p:nvSpPr>
+          <p:cNvPr id="9" name="TextBox 9">
+            <a:extLst>
+              <a:ext uri="{FF2B5EF4-FFF2-40B4-BE49-F238E27FC236}">
+                <a16:creationId xmlns:a16="http://schemas.microsoft.com/office/drawing/2014/main" id="{14969CE1-CB4C-4E02-97BC-B9DE55B4CEEF}"/>
+              </a:ext>
+            </a:extLst>
+          </p:cNvPr>
+          <p:cNvSpPr txBox="1"/>
+          <p:nvPr/>
+        </p:nvSpPr>
+        <p:spPr>
+          <a:xfrm>
+            <a:off x="762000" y="3448050"/>
+            <a:ext cx="6096000" cy="2009597"/>
+          </a:xfrm>
+        </p:spPr>
+        <p:txBody>
+          <a:bodyPr wrap="square" rtlCol="0" lIns="0" tIns="0" rIns="0" bIns="0" anchor="t"/>
+          <a:lstStyle/>
+          <a:p>
+            <a:pPr algn="l">
+              <a:lnSpc>
+                <a:spcPct val="118000"/>
+              </a:lnSpc>
+              <a:spcAft>
+                <a:spcPts val="400"/>
+              </a:spcAft>
+            </a:pPr>
+            <a:r>
+              <a:rPr sz="1250" b="1">
+                <a:solidFill>
+                  <a:srgbClr val="D9E2EC"/>
+                </a:solidFill>
+                <a:latin typeface="Segoe UI"/>
+                <a:ea typeface="Segoe UI"/>
+              </a:rPr>
+              <a:t>1 · Ver as 11 derivações do último snapshot</a:t>
+            </a:r>
+          </a:p>
+          <a:p>
+            <a:pPr algn="l">
+              <a:lnSpc>
+                <a:spcPct val="118000"/>
+              </a:lnSpc>
+              <a:spcAft>
+                <a:spcPts val="1400"/>
+              </a:spcAft>
+            </a:pPr>
+            <a:r>
+              <a:rPr sz="1150">
+                <a:solidFill>
+                  <a:srgbClr val="8B99A8"/>
+                </a:solidFill>
+                <a:latin typeface="Segoe UI"/>
+                <a:ea typeface="Segoe UI"/>
+              </a:rPr>
+              <a:t>O dashboard compara o estado desejado com o diretório simulado e lista o que saiu do padrão.</a:t>
+            </a:r>
+          </a:p>
+          <a:p>
+            <a:pPr algn="l">
+              <a:lnSpc>
+                <a:spcPct val="118000"/>
+              </a:lnSpc>
+              <a:spcAft>
+                <a:spcPts val="400"/>
+              </a:spcAft>
+            </a:pPr>
+            <a:r>
+              <a:rPr sz="1250" b="1">
+                <a:solidFill>
+                  <a:srgbClr val="D9E2EC"/>
+                </a:solidFill>
+                <a:latin typeface="Segoe UI"/>
+                <a:ea typeface="Segoe UI"/>
+              </a:rPr>
+              <a:t>2 · Rodar o -WhatIf e baixar o .ps1</a:t>
+            </a:r>
+          </a:p>
+          <a:p>
+            <a:pPr algn="l">
+              <a:lnSpc>
+                <a:spcPct val="118000"/>
+              </a:lnSpc>
+              <a:spcAft>
+                <a:spcPts val="1400"/>
+              </a:spcAft>
+            </a:pPr>
+            <a:r>
+              <a:rPr sz="1150">
+                <a:solidFill>
+                  <a:srgbClr val="8B99A8"/>
+                </a:solidFill>
+                <a:latin typeface="Segoe UI"/>
+                <a:ea typeface="Segoe UI"/>
+              </a:rPr>
+              <a:t>O plano vira PowerShell com guarda de idempotência e diário de reversão.</a:t>
+            </a:r>
+          </a:p>
+          <a:p>
+            <a:pPr algn="l">
+              <a:lnSpc>
+                <a:spcPct val="118000"/>
+              </a:lnSpc>
+              <a:spcAft>
+                <a:spcPts val="400"/>
+              </a:spcAft>
+            </a:pPr>
+            <a:r>
+              <a:rPr sz="1250" b="1">
+                <a:solidFill>
+                  <a:srgbClr val="D9E2EC"/>
+                </a:solidFill>
+                <a:latin typeface="Segoe UI"/>
+                <a:ea typeface="Segoe UI"/>
+              </a:rPr>
+              <a:t>3 · Simular uma adulteração na auditoria</a:t>
+            </a:r>
+          </a:p>
+          <a:p>
+            <a:pPr algn="l">
+              <a:lnSpc>
+                <a:spcPct val="118000"/>
+              </a:lnSpc>
+            </a:pPr>
+            <a:r>
+              <a:rPr sz="1150">
+                <a:solidFill>
+                  <a:srgbClr val="8B99A8"/>
+                </a:solidFill>
+                <a:latin typeface="Segoe UI"/>
+                <a:ea typeface="Segoe UI"/>
+              </a:rPr>
+              <a:t>Mudar um evento faz a validação acusar o elo exato onde a trilha foi rompida.</a:t>
+            </a:r>
+          </a:p>
+        </p:txBody>
+      </p:sp>
+      <p:sp>
+        <p:nvSpPr>
+          <p:cNvPr id="10" name="Shape 10">
+            <a:extLst>
+              <a:ext uri="{FF2B5EF4-FFF2-40B4-BE49-F238E27FC236}">
+                <a16:creationId xmlns:a16="http://schemas.microsoft.com/office/drawing/2014/main" id="{CA881A48-A15E-4BC9-B091-641280C89564}"/>
+              </a:ext>
+            </a:extLst>
+          </p:cNvPr>
+          <p:cNvSpPr/>
+          <p:nvPr/>
+        </p:nvSpPr>
+        <p:spPr>
+          <a:xfrm>
+            <a:off x="7334250" y="1485900"/>
+            <a:ext cx="3619500" cy="4152900"/>
+          </a:xfrm>
+          <a:prstGeom prst="roundRect">
+            <a:avLst/>
+          </a:prstGeom>
+          <a:solidFill>
+            <a:srgbClr val="FFFFFF"/>
+          </a:solidFill>
+          <a:ln w="12700">
+            <a:solidFill>
+              <a:srgbClr val="26313F"/>
+            </a:solidFill>
+          </a:ln>
+        </p:spPr>
+        <p:txBody>
+          <a:bodyPr wrap="square" rtlCol="0"/>
+          <a:lstStyle/>
+          <a:p>
+            <a:r>
+              <a:rPr/>
+              <a:t/>
+            </a:r>
+          </a:p>
+        </p:txBody>
+      </p:sp>
+      <p:sp>
+        <p:nvSpPr>
+          <p:cNvPr id="11" name="TextBox 11">
+            <a:extLst>
+              <a:ext uri="{FF2B5EF4-FFF2-40B4-BE49-F238E27FC236}">
+                <a16:creationId xmlns:a16="http://schemas.microsoft.com/office/drawing/2014/main" id="{A2471048-6A81-4D18-8C24-7316C8D16702}"/>
+              </a:ext>
+            </a:extLst>
+          </p:cNvPr>
+          <p:cNvSpPr txBox="1"/>
+          <p:nvPr/>
+        </p:nvSpPr>
+        <p:spPr>
+          <a:xfrm>
+            <a:off x="7486650" y="4876800"/>
+            <a:ext cx="3314700" cy="576478"/>
+          </a:xfrm>
+        </p:spPr>
+        <p:txBody>
+          <a:bodyPr wrap="square" rtlCol="0" lIns="0" tIns="0" rIns="0" bIns="0" anchor="t"/>
+          <a:lstStyle/>
+          <a:p>
+            <a:pPr algn="ctr">
+              <a:lnSpc>
+                <a:spcPct val="118000"/>
+              </a:lnSpc>
+              <a:spcAft>
+                <a:spcPts val="200"/>
+              </a:spcAft>
+            </a:pPr>
+            <a:r>
+              <a:rPr sz="1150" b="0">
+                <a:solidFill>
+                  <a:srgbClr val="4A5768"/>
+                </a:solidFill>
+                <a:latin typeface="Segoe UI"/>
+                <a:ea typeface="Segoe UI"/>
+              </a:rPr>
+              <a:t>Console de Automação de Identidade</a:t>
+            </a:r>
+          </a:p>
+          <a:p>
+            <a:pPr algn="ctr">
+              <a:lnSpc>
+                <a:spcPct val="110000"/>
+              </a:lnSpc>
+            </a:pPr>
+            <a:r>
+              <a:rPr b="0" sz="1150">
+                <a:solidFill>
+                  <a:srgbClr val="4A5768"/>
+                </a:solidFill>
+                <a:latin typeface="Consolas"/>
+                <a:ea typeface="Consolas"/>
+              </a:rPr>
+              <a:t>Aponte para abrir a demonstração</a:t>
+            </a:r>
+          </a:p>
+        </p:txBody>
+      </p:sp>
+      <p:sp>
+        <p:nvSpPr>
+          <p:cNvPr id="12" name="TextBox 12">
+            <a:extLst>
+              <a:ext uri="{FF2B5EF4-FFF2-40B4-BE49-F238E27FC236}">
+                <a16:creationId xmlns:a16="http://schemas.microsoft.com/office/drawing/2014/main" id="{DB1068E2-7A54-497C-80C5-81C013811BE3}"/>
+              </a:ext>
+            </a:extLst>
+          </p:cNvPr>
+          <p:cNvSpPr txBox="1"/>
+          <p:nvPr/>
+        </p:nvSpPr>
+        <p:spPr>
+          <a:xfrm>
+            <a:off x="762000" y="6096000"/>
+            <a:ext cx="10668000" cy="266700"/>
+          </a:xfrm>
+        </p:spPr>
+        <p:txBody>
+          <a:bodyPr wrap="square" rtlCol="0" lIns="0" tIns="0" rIns="0" bIns="0" anchor="t"/>
+          <a:lstStyle/>
+          <a:p>
+            <a:pPr algn="l">
+              <a:lnSpc>
+                <a:spcPct val="110000"/>
+              </a:lnSpc>
+            </a:pPr>
+            <a:r>
+              <a:rPr sz="1200">
+                <a:solidFill>
+                  <a:srgbClr val="63707E"/>
+                </a:solidFill>
+                <a:latin typeface="Segoe UI"/>
+                <a:ea typeface="Segoe UI"/>
+              </a:rPr>
+              <a:t>Demonstração com dados sintéticos da Contoso · nenhuma conta real é tocada · código aberto no repositório</a:t>
+            </a:r>
+          </a:p>
+        </p:txBody>
+      </p:sp>
+      <p:pic>
+        <p:nvPicPr>
+          <p:cNvPr id="13" name="Picture 13">
+            <a:extLst>
+              <a:ext uri="{FF2B5EF4-FFF2-40B4-BE49-F238E27FC236}">
+                <a16:creationId xmlns:a16="http://schemas.microsoft.com/office/drawing/2014/main" id="{8A9BFED7-A3A0-4BF7-AA74-0B95E95C8C7C}"/>
+              </a:ext>
+            </a:extLst>
+          </p:cNvPr>
+          <p:cNvPicPr/>
+          <p:nvPr/>
+        </p:nvPicPr>
+        <p:blipFill>
+          <a:blip r:embed="rId2"/>
+          <a:stretch>
+            <a:fillRect/>
+          </a:stretch>
+        </p:blipFill>
+        <p:spPr>
+          <a:xfrm>
+            <a:off x="7715250" y="1866900"/>
+            <a:ext cx="2857500" cy="2857500"/>
+          </a:xfrm>
+          <a:prstGeom prst="rect">
+            <a:avLst/>
+          </a:prstGeom>
+        </p:spPr>
+      </p:pic>
     </p:spTree>
   </p:cSld>
   <p:clrMapOvr>

</xml_diff>